<commit_message>
Regenerate sample decks for the new edge label sizing
The sample .pptx files are demonstration output of the generator, so they
have to be rebuilt whenever its geometry changes or they stop showing
what the tool actually produces.
</commit_message>
<xml_diff>
--- a/sample/graph1.pptx
+++ b/sample/graph1.pptx
@@ -120,7 +120,7 @@
               </a:lnSpc>
             </a:pPr>
             <a:r>
-              <a:rPr lang="ja-JP" altLang="en-US" sz="1450">
+              <a:rPr lang="ja-JP" altLang="en-US" sz="1400">
                 <a:solidFill>
                   <a:srgbClr val="333333"/>
                 </a:solidFill>
@@ -186,7 +186,7 @@
               </a:lnSpc>
             </a:pPr>
             <a:r>
-              <a:rPr lang="ja-JP" altLang="en-US" sz="1450">
+              <a:rPr lang="ja-JP" altLang="en-US" sz="1400">
                 <a:solidFill>
                   <a:srgbClr val="333333"/>
                 </a:solidFill>
@@ -231,7 +231,7 @@
               </a:lnSpc>
             </a:pPr>
             <a:r>
-              <a:rPr lang="ja-JP" altLang="en-US" sz="1450">
+              <a:rPr lang="ja-JP" altLang="en-US" sz="1400">
                 <a:solidFill>
                   <a:srgbClr val="5A4500"/>
                 </a:solidFill>
@@ -315,7 +315,7 @@
               </a:lnSpc>
             </a:pPr>
             <a:r>
-              <a:rPr lang="ja-JP" altLang="en-US" sz="1450">
+              <a:rPr lang="ja-JP" altLang="en-US" sz="1400">
                 <a:solidFill>
                   <a:srgbClr val="1A4314"/>
                 </a:solidFill>
@@ -360,7 +360,7 @@
               </a:lnSpc>
             </a:pPr>
             <a:r>
-              <a:rPr lang="ja-JP" altLang="en-US" sz="1450">
+              <a:rPr lang="ja-JP" altLang="en-US" sz="1400">
                 <a:solidFill>
                   <a:srgbClr val="7A1A1A"/>
                 </a:solidFill>
@@ -407,7 +407,7 @@
               </a:lnSpc>
             </a:pPr>
             <a:r>
-              <a:rPr lang="ja-JP" altLang="en-US" sz="1450">
+              <a:rPr lang="ja-JP" altLang="en-US" sz="1400">
                 <a:solidFill>
                   <a:srgbClr val="1A4314"/>
                 </a:solidFill>
@@ -452,7 +452,7 @@
               </a:lnSpc>
             </a:pPr>
             <a:r>
-              <a:rPr lang="ja-JP" altLang="en-US" sz="1450">
+              <a:rPr lang="ja-JP" altLang="en-US" sz="1400">
                 <a:solidFill>
                   <a:srgbClr val="333333"/>
                 </a:solidFill>
@@ -469,7 +469,7 @@
               </a:lnSpc>
             </a:pPr>
             <a:r>
-              <a:rPr lang="ja-JP" altLang="en-US" sz="1450">
+              <a:rPr lang="ja-JP" altLang="en-US" sz="1400">
                 <a:solidFill>
                   <a:srgbClr val="333333"/>
                 </a:solidFill>
@@ -516,7 +516,7 @@
               </a:lnSpc>
             </a:pPr>
             <a:r>
-              <a:rPr lang="ja-JP" altLang="en-US" sz="1450">
+              <a:rPr lang="ja-JP" altLang="en-US" sz="1400">
                 <a:solidFill>
                   <a:srgbClr val="1A4314"/>
                 </a:solidFill>
@@ -760,8 +760,8 @@
         </p:nvSpPr>
         <p:spPr>
           <a:xfrm>
-            <a:off x="5783040" y="2670456"/>
-            <a:ext cx="317838" cy="317838"/>
+            <a:off x="5753903" y="2670456"/>
+            <a:ext cx="376111" cy="317838"/>
           </a:xfrm>
           <a:prstGeom prst="roundRect">
             <a:avLst/>
@@ -776,7 +776,7 @@
           </a:ln>
         </p:spPr>
         <p:txBody>
-          <a:bodyPr rtlCol="0" anchor="ctr" lIns="18288" tIns="9144" rIns="18288" bIns="9144"/>
+          <a:bodyPr rtlCol="0" anchor="ctr" wrap="none" lIns="0" tIns="0" rIns="0" bIns="0"/>
           <a:lstStyle/>
           <a:p>
             <a:pPr algn="ctr">
@@ -785,7 +785,7 @@
               </a:lnSpc>
             </a:pPr>
             <a:r>
-              <a:rPr lang="ja-JP" altLang="en-US" sz="1450">
+              <a:rPr lang="ja-JP" altLang="en-US" sz="1400">
                 <a:solidFill>
                   <a:srgbClr val="333333"/>
                 </a:solidFill>
@@ -805,8 +805,8 @@
         </p:nvSpPr>
         <p:spPr>
           <a:xfrm>
-            <a:off x="5826903" y="3522141"/>
-            <a:ext cx="329544" cy="317838"/>
+            <a:off x="5797064" y="3522141"/>
+            <a:ext cx="389222" cy="317838"/>
           </a:xfrm>
           <a:prstGeom prst="roundRect">
             <a:avLst/>
@@ -821,7 +821,7 @@
           </a:ln>
         </p:spPr>
         <p:txBody>
-          <a:bodyPr rtlCol="0" anchor="ctr" lIns="18288" tIns="9144" rIns="18288" bIns="9144"/>
+          <a:bodyPr rtlCol="0" anchor="ctr" wrap="none" lIns="0" tIns="0" rIns="0" bIns="0"/>
           <a:lstStyle/>
           <a:p>
             <a:pPr algn="ctr">
@@ -830,7 +830,7 @@
               </a:lnSpc>
             </a:pPr>
             <a:r>
-              <a:rPr lang="ja-JP" altLang="en-US" sz="1450">
+              <a:rPr lang="ja-JP" altLang="en-US" sz="1400">
                 <a:solidFill>
                   <a:srgbClr val="333333"/>
                 </a:solidFill>

</xml_diff>

<commit_message>
Keep edge label text inside the box vertically too
The roundRect inset applies to all four sides, but labelBoxSize only
compensated horizontally, so the box was ~2.7px shorter than the text it
had to hold. A single line survived on the leading mermaid's measured
height already carries, but a two-line label (textH 48) got a usable
height of 46.9 and overflowed the background box.

Solving for min(w,h) in closed form covers both directions at once and
drops the special case for labels whose width is the shorter side.
</commit_message>
<xml_diff>
--- a/sample/graph1.pptx
+++ b/sample/graph1.pptx
@@ -760,8 +760,8 @@
         </p:nvSpPr>
         <p:spPr>
           <a:xfrm>
-            <a:off x="5753903" y="2670456"/>
-            <a:ext cx="376111" cy="317838"/>
+            <a:off x="5752224" y="2653262"/>
+            <a:ext cx="379468" cy="352225"/>
           </a:xfrm>
           <a:prstGeom prst="roundRect">
             <a:avLst/>
@@ -805,8 +805,8 @@
         </p:nvSpPr>
         <p:spPr>
           <a:xfrm>
-            <a:off x="5797064" y="3522141"/>
-            <a:ext cx="389222" cy="317838"/>
+            <a:off x="5795386" y="3504947"/>
+            <a:ext cx="392579" cy="352225"/>
           </a:xfrm>
           <a:prstGeom prst="roundRect">
             <a:avLst/>

</xml_diff>

<commit_message>
chore(sample): regenerate the demonstration decks
The label wrapping fix changes the emitted txBody of every node, cluster and
sequence label, so the tracked sample output no longer matched what the
generator produces. graph7 and graph8 are unchanged: their labels already went
through the text box path, which never wrapped.
</commit_message>
<xml_diff>
--- a/sample/graph1.pptx
+++ b/sample/graph1.pptx
@@ -111,7 +111,7 @@
           </a:ln>
         </p:spPr>
         <p:txBody>
-          <a:bodyPr rtlCol="0" anchor="ctr" lIns="18288" tIns="9144" rIns="18288" bIns="9144"/>
+          <a:bodyPr rtlCol="0" anchor="ctr" wrap="none" lIns="18288" tIns="9144" rIns="18288" bIns="9144"/>
           <a:lstStyle/>
           <a:p>
             <a:pPr algn="ctr">
@@ -177,7 +177,7 @@
           </a:ln>
         </p:spPr>
         <p:txBody>
-          <a:bodyPr rtlCol="0" anchor="ctr" lIns="18288" tIns="9144" rIns="18288" bIns="9144"/>
+          <a:bodyPr rtlCol="0" anchor="ctr" wrap="none" lIns="18288" tIns="9144" rIns="18288" bIns="9144"/>
           <a:lstStyle/>
           <a:p>
             <a:pPr algn="ctr">
@@ -222,7 +222,7 @@
           </a:ln>
         </p:spPr>
         <p:txBody>
-          <a:bodyPr rtlCol="0" anchor="ctr" lIns="18288" tIns="9144" rIns="18288" bIns="9144"/>
+          <a:bodyPr rtlCol="0" anchor="ctr" wrap="none" lIns="18288" tIns="9144" rIns="18288" bIns="9144"/>
           <a:lstStyle/>
           <a:p>
             <a:pPr algn="ctr">
@@ -306,7 +306,7 @@
           </a:ln>
         </p:spPr>
         <p:txBody>
-          <a:bodyPr rtlCol="0" anchor="ctr" lIns="18288" tIns="9144" rIns="18288" bIns="9144"/>
+          <a:bodyPr rtlCol="0" anchor="ctr" wrap="none" lIns="18288" tIns="9144" rIns="18288" bIns="9144"/>
           <a:lstStyle/>
           <a:p>
             <a:pPr algn="ctr">
@@ -351,7 +351,7 @@
           </a:ln>
         </p:spPr>
         <p:txBody>
-          <a:bodyPr rtlCol="0" anchor="ctr" lIns="18288" tIns="9144" rIns="18288" bIns="9144"/>
+          <a:bodyPr rtlCol="0" anchor="ctr" wrap="none" lIns="18288" tIns="9144" rIns="18288" bIns="9144"/>
           <a:lstStyle/>
           <a:p>
             <a:pPr algn="ctr">
@@ -398,7 +398,7 @@
           </a:ln>
         </p:spPr>
         <p:txBody>
-          <a:bodyPr rtlCol="0" anchor="ctr" lIns="18288" tIns="9144" rIns="18288" bIns="9144"/>
+          <a:bodyPr rtlCol="0" anchor="ctr" wrap="none" lIns="18288" tIns="9144" rIns="18288" bIns="9144"/>
           <a:lstStyle/>
           <a:p>
             <a:pPr algn="ctr">
@@ -443,7 +443,7 @@
           </a:ln>
         </p:spPr>
         <p:txBody>
-          <a:bodyPr rtlCol="0" anchor="ctr" lIns="18288" tIns="9144" rIns="18288" bIns="9144"/>
+          <a:bodyPr rtlCol="0" anchor="ctr" wrap="none" lIns="18288" tIns="9144" rIns="18288" bIns="9144"/>
           <a:lstStyle/>
           <a:p>
             <a:pPr algn="ctr">
@@ -507,7 +507,7 @@
           </a:ln>
         </p:spPr>
         <p:txBody>
-          <a:bodyPr rtlCol="0" anchor="ctr" lIns="18288" tIns="9144" rIns="18288" bIns="9144"/>
+          <a:bodyPr rtlCol="0" anchor="ctr" wrap="none" lIns="18288" tIns="9144" rIns="18288" bIns="9144"/>
           <a:lstStyle/>
           <a:p>
             <a:pPr algn="ctr">

</xml_diff>